<commit_message>
chore: fix hardcoded absolute paths after the project folder move; rebuild deck
</commit_message>
<xml_diff>
--- a/presentation/SmartHome-Defense.pptx
+++ b/presentation/SmartHome-Defense.pptx
@@ -3577,7 +3577,7 @@
                 <a:ea typeface="Pinar Black" pitchFamily="34" charset="-122"/>
                 <a:cs typeface="Pinar Black" pitchFamily="34" charset="-120"/>
               </a:rPr>
-              <a:t>EDGE AI</a:t>
+              <a:t>EDGE     AI</a:t>
             </a:r>
             <a:endParaRPr lang="en-US" sz="13000" dirty="0"/>
           </a:p>
@@ -3585,52 +3585,13 @@
       </p:sp>
       <p:sp>
         <p:nvSpPr>
-          <p:cNvPr id="3" name="Text 1"/>
-          <p:cNvSpPr/>
-          <p:nvPr/>
-        </p:nvSpPr>
-        <p:spPr>
-          <a:xfrm>
-            <a:off x="914400" y="2148840"/>
-            <a:ext cx="10360152" cy="365760"/>
-          </a:xfrm>
-          <a:prstGeom prst="rect">
-            <a:avLst/>
-          </a:prstGeom>
-          <a:noFill/>
-          <a:ln/>
-        </p:spPr>
-        <p:txBody>
-          <a:bodyPr wrap="square" lIns="0" tIns="0" rIns="0" bIns="0" rtlCol="0" anchor="ctr"/>
-          <a:lstStyle/>
-          <a:p>
-            <a:pPr marL="0" indent="0" algn="ctr" rtl="1">
-              <a:buNone/>
-            </a:pPr>
-            <a:r>
-              <a:rPr lang="en-US" sz="1500" b="1" dirty="0">
-                <a:solidFill>
-                  <a:srgbClr val="C9962E"/>
-                </a:solidFill>
-                <a:latin typeface="Sahel" pitchFamily="34" charset="0"/>
-                <a:ea typeface="Sahel" pitchFamily="34" charset="-122"/>
-                <a:cs typeface="Sahel" pitchFamily="34" charset="-120"/>
-              </a:rPr>
-              <a:t>بخش اصلی ارائه</a:t>
-            </a:r>
-            <a:endParaRPr lang="en-US" sz="1500" dirty="0"/>
-          </a:p>
-        </p:txBody>
-      </p:sp>
-      <p:sp>
-        <p:nvSpPr>
           <p:cNvPr id="4" name="Text 2"/>
           <p:cNvSpPr/>
           <p:nvPr/>
         </p:nvSpPr>
         <p:spPr>
           <a:xfrm>
-            <a:off x="914400" y="2560320"/>
+            <a:off x="914400" y="703524"/>
             <a:ext cx="10360152" cy="914400"/>
           </a:xfrm>
           <a:prstGeom prst="rect">
@@ -3694,7 +3655,51 @@
                 <a:ea typeface="Sahel" pitchFamily="34" charset="-122"/>
                 <a:cs typeface="Sahel" pitchFamily="34" charset="-120"/>
               </a:rPr>
-              <a:t>دو موتور هوشمند، هر دو روی یک میکروکنترلر کم‌توان</a:t>
+              <a:t>دو </a:t>
+            </a:r>
+            <a:r>
+              <a:rPr lang="en-US" sz="1600" dirty="0" err="1">
+                <a:solidFill>
+                  <a:srgbClr val="C7D4E3"/>
+                </a:solidFill>
+                <a:latin typeface="Sahel" pitchFamily="34" charset="0"/>
+                <a:ea typeface="Sahel" pitchFamily="34" charset="-122"/>
+                <a:cs typeface="Sahel" pitchFamily="34" charset="-120"/>
+              </a:rPr>
+              <a:t>موتور</a:t>
+            </a:r>
+            <a:r>
+              <a:rPr lang="en-US" sz="1600" dirty="0">
+                <a:solidFill>
+                  <a:srgbClr val="C7D4E3"/>
+                </a:solidFill>
+                <a:latin typeface="Sahel" pitchFamily="34" charset="0"/>
+                <a:ea typeface="Sahel" pitchFamily="34" charset="-122"/>
+                <a:cs typeface="Sahel" pitchFamily="34" charset="-120"/>
+              </a:rPr>
+              <a:t> </a:t>
+            </a:r>
+            <a:r>
+              <a:rPr lang="en-US" sz="1600" dirty="0" err="1">
+                <a:solidFill>
+                  <a:srgbClr val="C7D4E3"/>
+                </a:solidFill>
+                <a:latin typeface="Sahel" pitchFamily="34" charset="0"/>
+                <a:ea typeface="Sahel" pitchFamily="34" charset="-122"/>
+                <a:cs typeface="Sahel" pitchFamily="34" charset="-120"/>
+              </a:rPr>
+              <a:t>هوشمند</a:t>
+            </a:r>
+            <a:r>
+              <a:rPr lang="en-US" sz="1600" dirty="0">
+                <a:solidFill>
+                  <a:srgbClr val="C7D4E3"/>
+                </a:solidFill>
+                <a:latin typeface="Sahel" pitchFamily="34" charset="0"/>
+                <a:ea typeface="Sahel" pitchFamily="34" charset="-122"/>
+                <a:cs typeface="Sahel" pitchFamily="34" charset="-120"/>
+              </a:rPr>
+              <a:t> ، هر دو روی یک میکروکنترلر کم‌توان</a:t>
             </a:r>
             <a:endParaRPr lang="en-US" sz="1600" dirty="0"/>
           </a:p>
@@ -4143,273 +4148,625 @@
           </a:prstGeom>
         </p:spPr>
       </p:pic>
-      <p:sp>
-        <p:nvSpPr>
-          <p:cNvPr id="6" name="Text 3"/>
-          <p:cNvSpPr/>
-          <p:nvPr/>
-        </p:nvSpPr>
-        <p:spPr>
-          <a:xfrm>
-            <a:off x="4997196" y="5413248"/>
-            <a:ext cx="2377440" cy="274320"/>
-          </a:xfrm>
-          <a:prstGeom prst="rect">
-            <a:avLst/>
-          </a:prstGeom>
-          <a:noFill/>
-          <a:ln/>
-        </p:spPr>
-        <p:txBody>
-          <a:bodyPr wrap="square" lIns="0" tIns="0" rIns="0" bIns="0" rtlCol="0" anchor="ctr"/>
-          <a:lstStyle/>
-          <a:p>
-            <a:pPr marL="0" indent="0" algn="r" rtl="1">
-              <a:buNone/>
-            </a:pPr>
-            <a:r>
-              <a:rPr lang="en-US" sz="1200" dirty="0">
-                <a:solidFill>
-                  <a:srgbClr val="5B6B7E"/>
-                </a:solidFill>
-                <a:latin typeface="Sahel" pitchFamily="34" charset="0"/>
-                <a:ea typeface="Sahel" pitchFamily="34" charset="-122"/>
-                <a:cs typeface="Sahel" pitchFamily="34" charset="-120"/>
-              </a:rPr>
-              <a:t>منبع: گزارش پروژه — شکل ۶-۱</a:t>
-            </a:r>
-            <a:endParaRPr lang="en-US" sz="1200" dirty="0"/>
-          </a:p>
-        </p:txBody>
-      </p:sp>
-      <p:sp>
-        <p:nvSpPr>
-          <p:cNvPr id="7" name="Shape 4"/>
-          <p:cNvSpPr/>
-          <p:nvPr/>
-        </p:nvSpPr>
-        <p:spPr>
-          <a:xfrm>
-            <a:off x="7982712" y="5870448"/>
-            <a:ext cx="3749040" cy="658368"/>
-          </a:xfrm>
-          <a:prstGeom prst="roundRect">
-            <a:avLst>
-              <a:gd name="adj" fmla="val 9722"/>
-            </a:avLst>
-          </a:prstGeom>
-          <a:solidFill>
-            <a:srgbClr val="EAF0F7"/>
-          </a:solidFill>
-          <a:ln w="12700">
+      <p:grpSp>
+        <p:nvGrpSpPr>
+          <p:cNvPr id="15" name="Group 14">
+            <a:extLst>
+              <a:ext uri="{FF2B5EF4-FFF2-40B4-BE49-F238E27FC236}">
+                <a16:creationId xmlns:a16="http://schemas.microsoft.com/office/drawing/2014/main" id="{F0480964-BCC6-06DE-E968-73AE2DDD320A}"/>
+              </a:ext>
+            </a:extLst>
+          </p:cNvPr>
+          <p:cNvGrpSpPr/>
+          <p:nvPr/>
+        </p:nvGrpSpPr>
+        <p:grpSpPr>
+          <a:xfrm>
+            <a:off x="4600480" y="5386016"/>
+            <a:ext cx="2819456" cy="1144496"/>
+            <a:chOff x="4005072" y="5830599"/>
+            <a:chExt cx="3749040" cy="698217"/>
+          </a:xfrm>
+        </p:grpSpPr>
+        <p:sp>
+          <p:nvSpPr>
+            <p:cNvPr id="9" name="Shape 6"/>
+            <p:cNvSpPr/>
+            <p:nvPr/>
+          </p:nvSpPr>
+          <p:spPr>
+            <a:xfrm>
+              <a:off x="4005072" y="5870448"/>
+              <a:ext cx="3749040" cy="658368"/>
+            </a:xfrm>
+            <a:prstGeom prst="roundRect">
+              <a:avLst>
+                <a:gd name="adj" fmla="val 9722"/>
+              </a:avLst>
+            </a:prstGeom>
             <a:solidFill>
               <a:srgbClr val="EAF0F7"/>
             </a:solidFill>
-            <a:prstDash val="solid"/>
-          </a:ln>
-        </p:spPr>
-        <p:txBody>
-          <a:bodyPr/>
-          <a:lstStyle/>
-          <a:p>
-            <a:endParaRPr lang="fa-IR"/>
-          </a:p>
-        </p:txBody>
-      </p:sp>
-      <p:sp>
-        <p:nvSpPr>
-          <p:cNvPr id="8" name="Text 5"/>
-          <p:cNvSpPr/>
-          <p:nvPr/>
-        </p:nvSpPr>
-        <p:spPr>
-          <a:xfrm>
-            <a:off x="8119872" y="5870448"/>
-            <a:ext cx="3474720" cy="658368"/>
-          </a:xfrm>
-          <a:prstGeom prst="rect">
-            <a:avLst/>
-          </a:prstGeom>
-          <a:noFill/>
-          <a:ln/>
-        </p:spPr>
-        <p:txBody>
-          <a:bodyPr wrap="square" lIns="0" tIns="0" rIns="0" bIns="0" rtlCol="0" anchor="ctr"/>
-          <a:lstStyle/>
-          <a:p>
-            <a:pPr marL="0" indent="0" algn="r" rtl="1">
-              <a:lnSpc>
-                <a:spcPct val="115000"/>
-              </a:lnSpc>
-              <a:buNone/>
-            </a:pPr>
-            <a:r>
-              <a:rPr lang="en-US" sz="1150" dirty="0">
+            <a:ln w="12700">
+              <a:solidFill>
+                <a:srgbClr val="EAF0F7"/>
+              </a:solidFill>
+              <a:prstDash val="solid"/>
+            </a:ln>
+          </p:spPr>
+          <p:txBody>
+            <a:bodyPr/>
+            <a:lstStyle/>
+            <a:p>
+              <a:endParaRPr lang="fa-IR" dirty="0"/>
+            </a:p>
+          </p:txBody>
+        </p:sp>
+        <p:sp>
+          <p:nvSpPr>
+            <p:cNvPr id="10" name="Text 7"/>
+            <p:cNvSpPr/>
+            <p:nvPr/>
+          </p:nvSpPr>
+          <p:spPr>
+            <a:xfrm>
+              <a:off x="4194273" y="5830599"/>
+              <a:ext cx="3474720" cy="658368"/>
+            </a:xfrm>
+            <a:prstGeom prst="rect">
+              <a:avLst/>
+            </a:prstGeom>
+            <a:noFill/>
+            <a:ln/>
+          </p:spPr>
+          <p:txBody>
+            <a:bodyPr wrap="square" lIns="0" tIns="0" rIns="0" bIns="0" rtlCol="0" anchor="ctr"/>
+            <a:lstStyle/>
+            <a:p>
+              <a:pPr algn="ctr" rtl="1">
+                <a:lnSpc>
+                  <a:spcPct val="250000"/>
+                </a:lnSpc>
+              </a:pPr>
+              <a:r>
+                <a:rPr lang="fa-IR" sz="1300" b="1" dirty="0">
+                  <a:solidFill>
+                    <a:srgbClr val="1E3A5F"/>
+                  </a:solidFill>
+                  <a:latin typeface="Sahel" pitchFamily="34" charset="0"/>
+                  <a:ea typeface="Sahel" pitchFamily="34" charset="-122"/>
+                  <a:cs typeface="Sahel" pitchFamily="34" charset="-120"/>
+                </a:rPr>
+                <a:t>‫بافرهای بزرگ در </a:t>
+              </a:r>
+              <a:r>
+                <a:rPr lang="en-US" sz="1300" b="1" dirty="0">
+                  <a:solidFill>
+                    <a:srgbClr val="1E3A5F"/>
+                  </a:solidFill>
+                  <a:latin typeface="Sahel" pitchFamily="34" charset="0"/>
+                  <a:ea typeface="Sahel" pitchFamily="34" charset="-122"/>
+                  <a:cs typeface="Sahel" pitchFamily="34" charset="-120"/>
+                </a:rPr>
+                <a:t>PSRAM</a:t>
+              </a:r>
+              <a:endParaRPr lang="fa-IR" sz="1300" b="1" dirty="0">
                 <a:solidFill>
                   <a:srgbClr val="1E3A5F"/>
                 </a:solidFill>
                 <a:latin typeface="Sahel" pitchFamily="34" charset="0"/>
                 <a:ea typeface="Sahel" pitchFamily="34" charset="-122"/>
                 <a:cs typeface="Sahel" pitchFamily="34" charset="-120"/>
-              </a:rPr>
-              <a:t>صف ورودی عمق ۱ — پردازش سری‌شده، بدون تداخل حافظه</a:t>
-            </a:r>
-            <a:endParaRPr lang="en-US" sz="1150" dirty="0"/>
-          </a:p>
-        </p:txBody>
-      </p:sp>
-      <p:sp>
-        <p:nvSpPr>
-          <p:cNvPr id="9" name="Shape 6"/>
-          <p:cNvSpPr/>
-          <p:nvPr/>
-        </p:nvSpPr>
-        <p:spPr>
-          <a:xfrm>
-            <a:off x="4005072" y="5870448"/>
-            <a:ext cx="3749040" cy="658368"/>
-          </a:xfrm>
-          <a:prstGeom prst="roundRect">
-            <a:avLst>
-              <a:gd name="adj" fmla="val 9722"/>
-            </a:avLst>
-          </a:prstGeom>
-          <a:solidFill>
-            <a:srgbClr val="EAF0F7"/>
-          </a:solidFill>
-          <a:ln w="12700">
+              </a:endParaRPr>
+            </a:p>
+            <a:p>
+              <a:pPr algn="ctr" rtl="1">
+                <a:lnSpc>
+                  <a:spcPct val="250000"/>
+                </a:lnSpc>
+              </a:pPr>
+              <a:r>
+                <a:rPr lang="fa-IR" sz="1300" b="1" dirty="0">
+                  <a:solidFill>
+                    <a:srgbClr val="1E3A5F"/>
+                  </a:solidFill>
+                  <a:latin typeface="Sahel" pitchFamily="34" charset="0"/>
+                  <a:ea typeface="Sahel" pitchFamily="34" charset="-122"/>
+                  <a:cs typeface="Sahel" pitchFamily="34" charset="-120"/>
+                </a:rPr>
+                <a:t>تا حافظه داخلی برای </a:t>
+              </a:r>
+              <a:r>
+                <a:rPr lang="en-US" sz="1300" b="1" dirty="0">
+                  <a:solidFill>
+                    <a:srgbClr val="1E3A5F"/>
+                  </a:solidFill>
+                  <a:latin typeface="Sahel" pitchFamily="34" charset="0"/>
+                  <a:ea typeface="Sahel" pitchFamily="34" charset="-122"/>
+                  <a:cs typeface="Sahel" pitchFamily="34" charset="-120"/>
+                </a:rPr>
+                <a:t> TLS </a:t>
+              </a:r>
+              <a:r>
+                <a:rPr lang="fa-IR" sz="1300" b="1" dirty="0">
+                  <a:solidFill>
+                    <a:srgbClr val="1E3A5F"/>
+                  </a:solidFill>
+                  <a:latin typeface="Sahel" pitchFamily="34" charset="0"/>
+                  <a:ea typeface="Sahel" pitchFamily="34" charset="-122"/>
+                  <a:cs typeface="Sahel" pitchFamily="34" charset="-120"/>
+                </a:rPr>
+                <a:t>آزاد بماند</a:t>
+              </a:r>
+            </a:p>
+          </p:txBody>
+        </p:sp>
+      </p:grpSp>
+      <p:grpSp>
+        <p:nvGrpSpPr>
+          <p:cNvPr id="16" name="Group 15">
+            <a:extLst>
+              <a:ext uri="{FF2B5EF4-FFF2-40B4-BE49-F238E27FC236}">
+                <a16:creationId xmlns:a16="http://schemas.microsoft.com/office/drawing/2014/main" id="{78930DF1-A1EA-4FD2-0667-1129921FB668}"/>
+              </a:ext>
+            </a:extLst>
+          </p:cNvPr>
+          <p:cNvGrpSpPr/>
+          <p:nvPr/>
+        </p:nvGrpSpPr>
+        <p:grpSpPr>
+          <a:xfrm>
+            <a:off x="7527004" y="5449640"/>
+            <a:ext cx="2755423" cy="1079175"/>
+            <a:chOff x="7982712" y="5870448"/>
+            <a:chExt cx="3749040" cy="658368"/>
+          </a:xfrm>
+        </p:grpSpPr>
+        <p:sp>
+          <p:nvSpPr>
+            <p:cNvPr id="7" name="Shape 4"/>
+            <p:cNvSpPr/>
+            <p:nvPr/>
+          </p:nvSpPr>
+          <p:spPr>
+            <a:xfrm>
+              <a:off x="7982712" y="5870448"/>
+              <a:ext cx="3749040" cy="658368"/>
+            </a:xfrm>
+            <a:prstGeom prst="roundRect">
+              <a:avLst>
+                <a:gd name="adj" fmla="val 9722"/>
+              </a:avLst>
+            </a:prstGeom>
             <a:solidFill>
               <a:srgbClr val="EAF0F7"/>
             </a:solidFill>
-            <a:prstDash val="solid"/>
-          </a:ln>
-        </p:spPr>
-        <p:txBody>
-          <a:bodyPr/>
-          <a:lstStyle/>
-          <a:p>
-            <a:endParaRPr lang="fa-IR"/>
-          </a:p>
-        </p:txBody>
-      </p:sp>
-      <p:sp>
-        <p:nvSpPr>
-          <p:cNvPr id="10" name="Text 7"/>
-          <p:cNvSpPr/>
-          <p:nvPr/>
-        </p:nvSpPr>
-        <p:spPr>
-          <a:xfrm>
-            <a:off x="4142232" y="5870448"/>
-            <a:ext cx="3474720" cy="658368"/>
-          </a:xfrm>
-          <a:prstGeom prst="rect">
-            <a:avLst/>
-          </a:prstGeom>
-          <a:noFill/>
-          <a:ln/>
-        </p:spPr>
-        <p:txBody>
-          <a:bodyPr wrap="square" lIns="0" tIns="0" rIns="0" bIns="0" rtlCol="0" anchor="ctr"/>
-          <a:lstStyle/>
-          <a:p>
-            <a:pPr marL="0" indent="0" algn="r" rtl="1">
-              <a:lnSpc>
-                <a:spcPct val="115000"/>
-              </a:lnSpc>
-              <a:buNone/>
-            </a:pPr>
-            <a:r>
-              <a:rPr lang="en-US" sz="1150" dirty="0">
+            <a:ln w="12700">
+              <a:solidFill>
+                <a:srgbClr val="EAF0F7"/>
+              </a:solidFill>
+              <a:prstDash val="solid"/>
+            </a:ln>
+          </p:spPr>
+          <p:txBody>
+            <a:bodyPr/>
+            <a:lstStyle/>
+            <a:p>
+              <a:endParaRPr lang="fa-IR"/>
+            </a:p>
+          </p:txBody>
+        </p:sp>
+        <p:sp>
+          <p:nvSpPr>
+            <p:cNvPr id="8" name="Text 5"/>
+            <p:cNvSpPr/>
+            <p:nvPr/>
+          </p:nvSpPr>
+          <p:spPr>
+            <a:xfrm>
+              <a:off x="8119872" y="5870448"/>
+              <a:ext cx="3474720" cy="658368"/>
+            </a:xfrm>
+            <a:prstGeom prst="rect">
+              <a:avLst/>
+            </a:prstGeom>
+            <a:noFill/>
+            <a:ln/>
+          </p:spPr>
+          <p:txBody>
+            <a:bodyPr wrap="square" lIns="0" tIns="0" rIns="0" bIns="0" rtlCol="0" anchor="ctr"/>
+            <a:lstStyle/>
+            <a:p>
+              <a:pPr marL="0" indent="0" algn="ctr" rtl="1">
+                <a:lnSpc>
+                  <a:spcPct val="150000"/>
+                </a:lnSpc>
+                <a:buNone/>
+              </a:pPr>
+              <a:r>
+                <a:rPr lang="en-US" sz="1300" b="1" dirty="0" err="1">
+                  <a:solidFill>
+                    <a:srgbClr val="1E3A5F"/>
+                  </a:solidFill>
+                  <a:latin typeface="Sahel" pitchFamily="34" charset="0"/>
+                  <a:ea typeface="Sahel" pitchFamily="34" charset="-122"/>
+                  <a:cs typeface="Sahel" pitchFamily="34" charset="-120"/>
+                </a:rPr>
+                <a:t>صف</a:t>
+              </a:r>
+              <a:r>
+                <a:rPr lang="en-US" sz="1300" b="1" dirty="0">
+                  <a:solidFill>
+                    <a:srgbClr val="1E3A5F"/>
+                  </a:solidFill>
+                  <a:latin typeface="Sahel" pitchFamily="34" charset="0"/>
+                  <a:ea typeface="Sahel" pitchFamily="34" charset="-122"/>
+                  <a:cs typeface="Sahel" pitchFamily="34" charset="-120"/>
+                </a:rPr>
+                <a:t> </a:t>
+              </a:r>
+              <a:r>
+                <a:rPr lang="en-US" sz="1300" b="1" dirty="0" err="1">
+                  <a:solidFill>
+                    <a:srgbClr val="1E3A5F"/>
+                  </a:solidFill>
+                  <a:latin typeface="Sahel" pitchFamily="34" charset="0"/>
+                  <a:ea typeface="Sahel" pitchFamily="34" charset="-122"/>
+                  <a:cs typeface="Sahel" pitchFamily="34" charset="-120"/>
+                </a:rPr>
+                <a:t>ورودی</a:t>
+              </a:r>
+              <a:r>
+                <a:rPr lang="fa-IR" sz="1300" b="1" dirty="0">
+                  <a:solidFill>
+                    <a:srgbClr val="1E3A5F"/>
+                  </a:solidFill>
+                  <a:latin typeface="Sahel" pitchFamily="34" charset="0"/>
+                  <a:ea typeface="Sahel" pitchFamily="34" charset="-122"/>
+                  <a:cs typeface="Sahel" pitchFamily="34" charset="-120"/>
+                </a:rPr>
+                <a:t> به</a:t>
+              </a:r>
+              <a:r>
+                <a:rPr lang="en-US" sz="1300" b="1" dirty="0">
+                  <a:solidFill>
+                    <a:srgbClr val="1E3A5F"/>
+                  </a:solidFill>
+                  <a:latin typeface="Sahel" pitchFamily="34" charset="0"/>
+                  <a:ea typeface="Sahel" pitchFamily="34" charset="-122"/>
+                  <a:cs typeface="Sahel" pitchFamily="34" charset="-120"/>
+                </a:rPr>
+                <a:t> </a:t>
+              </a:r>
+              <a:r>
+                <a:rPr lang="en-US" sz="1300" b="1" dirty="0" err="1">
+                  <a:solidFill>
+                    <a:srgbClr val="1E3A5F"/>
+                  </a:solidFill>
+                  <a:latin typeface="Sahel" pitchFamily="34" charset="0"/>
+                  <a:ea typeface="Sahel" pitchFamily="34" charset="-122"/>
+                  <a:cs typeface="Sahel" pitchFamily="34" charset="-120"/>
+                </a:rPr>
+                <a:t>عمق</a:t>
+              </a:r>
+              <a:r>
+                <a:rPr lang="en-US" sz="1300" b="1" dirty="0">
+                  <a:solidFill>
+                    <a:srgbClr val="1E3A5F"/>
+                  </a:solidFill>
+                  <a:latin typeface="Sahel" pitchFamily="34" charset="0"/>
+                  <a:ea typeface="Sahel" pitchFamily="34" charset="-122"/>
+                  <a:cs typeface="Sahel" pitchFamily="34" charset="-120"/>
+                </a:rPr>
+                <a:t> ۱</a:t>
+              </a:r>
+            </a:p>
+            <a:p>
+              <a:pPr marL="0" indent="0" algn="ctr" rtl="1">
+                <a:lnSpc>
+                  <a:spcPct val="150000"/>
+                </a:lnSpc>
+                <a:buNone/>
+              </a:pPr>
+              <a:r>
+                <a:rPr lang="en-US" sz="1300" b="1" dirty="0" err="1">
+                  <a:solidFill>
+                    <a:srgbClr val="1E3A5F"/>
+                  </a:solidFill>
+                  <a:latin typeface="Sahel" pitchFamily="34" charset="0"/>
+                  <a:ea typeface="Sahel" pitchFamily="34" charset="-122"/>
+                  <a:cs typeface="Sahel" pitchFamily="34" charset="-120"/>
+                </a:rPr>
+                <a:t>پردازش</a:t>
+              </a:r>
+              <a:r>
+                <a:rPr lang="en-US" sz="1300" b="1" dirty="0">
+                  <a:solidFill>
+                    <a:srgbClr val="1E3A5F"/>
+                  </a:solidFill>
+                  <a:latin typeface="Sahel" pitchFamily="34" charset="0"/>
+                  <a:ea typeface="Sahel" pitchFamily="34" charset="-122"/>
+                  <a:cs typeface="Sahel" pitchFamily="34" charset="-120"/>
+                </a:rPr>
+                <a:t> </a:t>
+              </a:r>
+              <a:r>
+                <a:rPr lang="en-US" sz="1300" b="1" dirty="0" err="1">
+                  <a:solidFill>
+                    <a:srgbClr val="1E3A5F"/>
+                  </a:solidFill>
+                  <a:latin typeface="Sahel" pitchFamily="34" charset="0"/>
+                  <a:ea typeface="Sahel" pitchFamily="34" charset="-122"/>
+                  <a:cs typeface="Sahel" pitchFamily="34" charset="-120"/>
+                </a:rPr>
+                <a:t>سری‌شده</a:t>
+              </a:r>
+              <a:endParaRPr lang="en-US" sz="1300" b="1" dirty="0">
                 <a:solidFill>
                   <a:srgbClr val="1E3A5F"/>
                 </a:solidFill>
                 <a:latin typeface="Sahel" pitchFamily="34" charset="0"/>
                 <a:ea typeface="Sahel" pitchFamily="34" charset="-122"/>
                 <a:cs typeface="Sahel" pitchFamily="34" charset="-120"/>
-              </a:rPr>
-              <a:t>بافرهای بزرگ در PSRAM — حافظه داخلی برای TLS آزاد می‌ماند</a:t>
-            </a:r>
-            <a:endParaRPr lang="en-US" sz="1150" dirty="0"/>
-          </a:p>
-        </p:txBody>
-      </p:sp>
-      <p:sp>
-        <p:nvSpPr>
-          <p:cNvPr id="11" name="Shape 8"/>
-          <p:cNvSpPr/>
-          <p:nvPr/>
-        </p:nvSpPr>
-        <p:spPr>
-          <a:xfrm>
-            <a:off x="27432" y="5870448"/>
-            <a:ext cx="3749040" cy="658368"/>
-          </a:xfrm>
-          <a:prstGeom prst="roundRect">
-            <a:avLst>
-              <a:gd name="adj" fmla="val 9722"/>
-            </a:avLst>
-          </a:prstGeom>
-          <a:solidFill>
-            <a:srgbClr val="EAF0F7"/>
-          </a:solidFill>
-          <a:ln w="12700">
+              </a:endParaRPr>
+            </a:p>
+            <a:p>
+              <a:pPr marL="0" indent="0" algn="ctr" rtl="1">
+                <a:lnSpc>
+                  <a:spcPct val="150000"/>
+                </a:lnSpc>
+                <a:buNone/>
+              </a:pPr>
+              <a:r>
+                <a:rPr lang="en-US" sz="1300" b="1" dirty="0" err="1">
+                  <a:solidFill>
+                    <a:srgbClr val="1E3A5F"/>
+                  </a:solidFill>
+                  <a:latin typeface="Sahel" pitchFamily="34" charset="0"/>
+                  <a:ea typeface="Sahel" pitchFamily="34" charset="-122"/>
+                  <a:cs typeface="Sahel" pitchFamily="34" charset="-120"/>
+                </a:rPr>
+                <a:t>بدون</a:t>
+              </a:r>
+              <a:r>
+                <a:rPr lang="en-US" sz="1300" b="1" dirty="0">
+                  <a:solidFill>
+                    <a:srgbClr val="1E3A5F"/>
+                  </a:solidFill>
+                  <a:latin typeface="Sahel" pitchFamily="34" charset="0"/>
+                  <a:ea typeface="Sahel" pitchFamily="34" charset="-122"/>
+                  <a:cs typeface="Sahel" pitchFamily="34" charset="-120"/>
+                </a:rPr>
+                <a:t> تداخل حافظه</a:t>
+              </a:r>
+              <a:endParaRPr lang="en-US" sz="1300" b="1" dirty="0"/>
+            </a:p>
+          </p:txBody>
+        </p:sp>
+      </p:grpSp>
+      <p:grpSp>
+        <p:nvGrpSpPr>
+          <p:cNvPr id="14" name="Group 13">
+            <a:extLst>
+              <a:ext uri="{FF2B5EF4-FFF2-40B4-BE49-F238E27FC236}">
+                <a16:creationId xmlns:a16="http://schemas.microsoft.com/office/drawing/2014/main" id="{CA205148-93C1-09E4-8404-BDF473D05762}"/>
+              </a:ext>
+            </a:extLst>
+          </p:cNvPr>
+          <p:cNvGrpSpPr/>
+          <p:nvPr/>
+        </p:nvGrpSpPr>
+        <p:grpSpPr>
+          <a:xfrm>
+            <a:off x="1901952" y="5449641"/>
+            <a:ext cx="2596478" cy="1079175"/>
+            <a:chOff x="27432" y="5870448"/>
+            <a:chExt cx="3749040" cy="658368"/>
+          </a:xfrm>
+        </p:grpSpPr>
+        <p:sp>
+          <p:nvSpPr>
+            <p:cNvPr id="11" name="Shape 8"/>
+            <p:cNvSpPr/>
+            <p:nvPr/>
+          </p:nvSpPr>
+          <p:spPr>
+            <a:xfrm>
+              <a:off x="27432" y="5870448"/>
+              <a:ext cx="3749040" cy="658368"/>
+            </a:xfrm>
+            <a:prstGeom prst="roundRect">
+              <a:avLst>
+                <a:gd name="adj" fmla="val 9722"/>
+              </a:avLst>
+            </a:prstGeom>
             <a:solidFill>
               <a:srgbClr val="EAF0F7"/>
             </a:solidFill>
-            <a:prstDash val="solid"/>
-          </a:ln>
-        </p:spPr>
-        <p:txBody>
-          <a:bodyPr/>
-          <a:lstStyle/>
-          <a:p>
-            <a:endParaRPr lang="fa-IR"/>
-          </a:p>
-        </p:txBody>
-      </p:sp>
-      <p:sp>
-        <p:nvSpPr>
-          <p:cNvPr id="12" name="Text 9"/>
-          <p:cNvSpPr/>
-          <p:nvPr/>
-        </p:nvSpPr>
-        <p:spPr>
-          <a:xfrm>
-            <a:off x="164592" y="5870448"/>
-            <a:ext cx="3474720" cy="658368"/>
-          </a:xfrm>
-          <a:prstGeom prst="rect">
-            <a:avLst/>
-          </a:prstGeom>
-          <a:noFill/>
-          <a:ln/>
-        </p:spPr>
-        <p:txBody>
-          <a:bodyPr wrap="square" lIns="0" tIns="0" rIns="0" bIns="0" rtlCol="0" anchor="ctr"/>
-          <a:lstStyle/>
-          <a:p>
-            <a:pPr marL="0" indent="0" algn="r" rtl="1">
-              <a:lnSpc>
-                <a:spcPct val="115000"/>
-              </a:lnSpc>
-              <a:buNone/>
-            </a:pPr>
-            <a:r>
-              <a:rPr lang="en-US" sz="1150" dirty="0">
+            <a:ln w="12700">
+              <a:solidFill>
+                <a:srgbClr val="EAF0F7"/>
+              </a:solidFill>
+              <a:prstDash val="solid"/>
+            </a:ln>
+          </p:spPr>
+          <p:txBody>
+            <a:bodyPr/>
+            <a:lstStyle/>
+            <a:p>
+              <a:endParaRPr lang="fa-IR"/>
+            </a:p>
+          </p:txBody>
+        </p:sp>
+        <p:sp>
+          <p:nvSpPr>
+            <p:cNvPr id="12" name="Text 9"/>
+            <p:cNvSpPr/>
+            <p:nvPr/>
+          </p:nvSpPr>
+          <p:spPr>
+            <a:xfrm>
+              <a:off x="164592" y="5870448"/>
+              <a:ext cx="3474720" cy="658368"/>
+            </a:xfrm>
+            <a:prstGeom prst="rect">
+              <a:avLst/>
+            </a:prstGeom>
+            <a:noFill/>
+            <a:ln/>
+          </p:spPr>
+          <p:txBody>
+            <a:bodyPr wrap="square" lIns="0" tIns="0" rIns="0" bIns="0" rtlCol="0" anchor="ctr"/>
+            <a:lstStyle/>
+            <a:p>
+              <a:pPr marL="0" indent="0" algn="ctr" rtl="1">
+                <a:lnSpc>
+                  <a:spcPct val="150000"/>
+                </a:lnSpc>
+                <a:buNone/>
+              </a:pPr>
+              <a:r>
+                <a:rPr lang="en-US" sz="1300" b="1" dirty="0">
+                  <a:solidFill>
+                    <a:srgbClr val="1E3A5F"/>
+                  </a:solidFill>
+                  <a:latin typeface="Sahel" pitchFamily="34" charset="0"/>
+                  <a:ea typeface="Sahel" pitchFamily="34" charset="-122"/>
+                  <a:cs typeface="Sahel" pitchFamily="34" charset="-120"/>
+                </a:rPr>
+                <a:t>تحویل غیرمسدودکننده </a:t>
+              </a:r>
+              <a:r>
+                <a:rPr lang="en-US" sz="1300" b="1" dirty="0" err="1">
+                  <a:solidFill>
+                    <a:srgbClr val="1E3A5F"/>
+                  </a:solidFill>
+                  <a:latin typeface="Sahel" pitchFamily="34" charset="0"/>
+                  <a:ea typeface="Sahel" pitchFamily="34" charset="-122"/>
+                  <a:cs typeface="Sahel" pitchFamily="34" charset="-120"/>
+                </a:rPr>
+                <a:t>با</a:t>
+              </a:r>
+              <a:r>
+                <a:rPr lang="en-US" sz="1300" b="1" dirty="0">
+                  <a:solidFill>
+                    <a:srgbClr val="1E3A5F"/>
+                  </a:solidFill>
+                  <a:latin typeface="Sahel" pitchFamily="34" charset="0"/>
+                  <a:ea typeface="Sahel" pitchFamily="34" charset="-122"/>
+                  <a:cs typeface="Sahel" pitchFamily="34" charset="-120"/>
+                </a:rPr>
+                <a:t> </a:t>
+              </a:r>
+              <a:r>
+                <a:rPr lang="en-US" sz="1300" b="1" dirty="0" err="1">
+                  <a:solidFill>
+                    <a:srgbClr val="1E3A5F"/>
+                  </a:solidFill>
+                  <a:latin typeface="Sahel" pitchFamily="34" charset="0"/>
+                  <a:ea typeface="Sahel" pitchFamily="34" charset="-122"/>
+                  <a:cs typeface="Sahel" pitchFamily="34" charset="-120"/>
+                </a:rPr>
+                <a:t>وظیفه</a:t>
+              </a:r>
+              <a:r>
+                <a:rPr lang="en-US" sz="1300" b="1" dirty="0">
+                  <a:solidFill>
+                    <a:srgbClr val="1E3A5F"/>
+                  </a:solidFill>
+                  <a:latin typeface="Sahel" pitchFamily="34" charset="0"/>
+                  <a:ea typeface="Sahel" pitchFamily="34" charset="-122"/>
+                  <a:cs typeface="Sahel" pitchFamily="34" charset="-120"/>
+                </a:rPr>
+                <a:t> </a:t>
+              </a:r>
+              <a:r>
+                <a:rPr lang="en-US" sz="1300" b="1" dirty="0" err="1">
+                  <a:solidFill>
+                    <a:srgbClr val="1E3A5F"/>
+                  </a:solidFill>
+                  <a:latin typeface="Sahel" pitchFamily="34" charset="0"/>
+                  <a:ea typeface="Sahel" pitchFamily="34" charset="-122"/>
+                  <a:cs typeface="Sahel" pitchFamily="34" charset="-120"/>
+                </a:rPr>
+                <a:t>face_worker</a:t>
+              </a:r>
+              <a:endParaRPr lang="en-US" sz="1300" b="1" dirty="0">
                 <a:solidFill>
                   <a:srgbClr val="1E3A5F"/>
                 </a:solidFill>
                 <a:latin typeface="Sahel" pitchFamily="34" charset="0"/>
                 <a:ea typeface="Sahel" pitchFamily="34" charset="-122"/>
                 <a:cs typeface="Sahel" pitchFamily="34" charset="-120"/>
-              </a:rPr>
-              <a:t>تحویل غیرمسدودکننده با وظیفه face_worker — UI پاسخ‌گو می‌ماند</a:t>
-            </a:r>
-            <a:endParaRPr lang="en-US" sz="1150" dirty="0"/>
-          </a:p>
-        </p:txBody>
-      </p:sp>
+              </a:endParaRPr>
+            </a:p>
+            <a:p>
+              <a:pPr marL="0" indent="0" algn="ctr" rtl="1">
+                <a:lnSpc>
+                  <a:spcPct val="150000"/>
+                </a:lnSpc>
+                <a:buNone/>
+              </a:pPr>
+              <a:r>
+                <a:rPr lang="fa-IR" sz="1300" b="1" dirty="0">
+                  <a:solidFill>
+                    <a:srgbClr val="1E3A5F"/>
+                  </a:solidFill>
+                  <a:latin typeface="Sahel" pitchFamily="34" charset="0"/>
+                  <a:ea typeface="Sahel" pitchFamily="34" charset="-122"/>
+                  <a:cs typeface="Sahel" pitchFamily="34" charset="-120"/>
+                </a:rPr>
+                <a:t>برای اینکه</a:t>
+              </a:r>
+              <a:r>
+                <a:rPr lang="en-US" sz="1300" b="1" dirty="0">
+                  <a:solidFill>
+                    <a:srgbClr val="1E3A5F"/>
+                  </a:solidFill>
+                  <a:latin typeface="Sahel" pitchFamily="34" charset="0"/>
+                  <a:ea typeface="Sahel" pitchFamily="34" charset="-122"/>
+                  <a:cs typeface="Sahel" pitchFamily="34" charset="-120"/>
+                </a:rPr>
+                <a:t> UI </a:t>
+              </a:r>
+              <a:r>
+                <a:rPr lang="en-US" sz="1300" b="1" dirty="0" err="1">
+                  <a:solidFill>
+                    <a:srgbClr val="1E3A5F"/>
+                  </a:solidFill>
+                  <a:latin typeface="Sahel" pitchFamily="34" charset="0"/>
+                  <a:ea typeface="Sahel" pitchFamily="34" charset="-122"/>
+                  <a:cs typeface="Sahel" pitchFamily="34" charset="-120"/>
+                </a:rPr>
+                <a:t>پاسخ‌گو</a:t>
+              </a:r>
+              <a:r>
+                <a:rPr lang="en-US" sz="1300" b="1" dirty="0">
+                  <a:solidFill>
+                    <a:srgbClr val="1E3A5F"/>
+                  </a:solidFill>
+                  <a:latin typeface="Sahel" pitchFamily="34" charset="0"/>
+                  <a:ea typeface="Sahel" pitchFamily="34" charset="-122"/>
+                  <a:cs typeface="Sahel" pitchFamily="34" charset="-120"/>
+                </a:rPr>
+                <a:t> </a:t>
+              </a:r>
+              <a:r>
+                <a:rPr lang="fa-IR" sz="1300" b="1" dirty="0">
+                  <a:solidFill>
+                    <a:srgbClr val="1E3A5F"/>
+                  </a:solidFill>
+                  <a:latin typeface="Sahel" pitchFamily="34" charset="0"/>
+                  <a:ea typeface="Sahel" pitchFamily="34" charset="-122"/>
+                  <a:cs typeface="Sahel" pitchFamily="34" charset="-120"/>
+                </a:rPr>
+                <a:t>بماند</a:t>
+              </a:r>
+              <a:endParaRPr lang="en-US" sz="1300" b="1" dirty="0"/>
+            </a:p>
+          </p:txBody>
+        </p:sp>
+      </p:grpSp>
       <p:sp>
         <p:nvSpPr>
           <p:cNvPr id="13" name="Text 10"/>
@@ -7543,45 +7900,6 @@
           </a:prstGeom>
         </p:spPr>
       </p:pic>
-      <p:sp>
-        <p:nvSpPr>
-          <p:cNvPr id="6" name="Text 3"/>
-          <p:cNvSpPr/>
-          <p:nvPr/>
-        </p:nvSpPr>
-        <p:spPr>
-          <a:xfrm>
-            <a:off x="4082796" y="6382512"/>
-            <a:ext cx="4206240" cy="274320"/>
-          </a:xfrm>
-          <a:prstGeom prst="rect">
-            <a:avLst/>
-          </a:prstGeom>
-          <a:noFill/>
-          <a:ln/>
-        </p:spPr>
-        <p:txBody>
-          <a:bodyPr wrap="square" lIns="0" tIns="0" rIns="0" bIns="0" rtlCol="0" anchor="ctr"/>
-          <a:lstStyle/>
-          <a:p>
-            <a:pPr marL="0" indent="0" algn="r" rtl="1">
-              <a:buNone/>
-            </a:pPr>
-            <a:r>
-              <a:rPr lang="en-US" sz="1200" dirty="0">
-                <a:solidFill>
-                  <a:srgbClr val="5B6B7E"/>
-                </a:solidFill>
-                <a:latin typeface="Sahel" pitchFamily="34" charset="0"/>
-                <a:ea typeface="Sahel" pitchFamily="34" charset="-122"/>
-                <a:cs typeface="Sahel" pitchFamily="34" charset="-120"/>
-              </a:rPr>
-              <a:t>منبع: گزارش پروژه — شکل مدل عامل رفتاری (fig_ml_model)</a:t>
-            </a:r>
-            <a:endParaRPr lang="en-US" sz="1200" dirty="0"/>
-          </a:p>
-        </p:txBody>
-      </p:sp>
       <p:sp>
         <p:nvSpPr>
           <p:cNvPr id="7" name="Text 4"/>
@@ -9224,45 +9542,6 @@
       </p:graphicFrame>
       <p:sp>
         <p:nvSpPr>
-          <p:cNvPr id="5" name="Text 2"/>
-          <p:cNvSpPr/>
-          <p:nvPr/>
-        </p:nvSpPr>
-        <p:spPr>
-          <a:xfrm>
-            <a:off x="457200" y="6309360"/>
-            <a:ext cx="5120640" cy="320040"/>
-          </a:xfrm>
-          <a:prstGeom prst="rect">
-            <a:avLst/>
-          </a:prstGeom>
-          <a:noFill/>
-          <a:ln/>
-        </p:spPr>
-        <p:txBody>
-          <a:bodyPr wrap="square" lIns="0" tIns="0" rIns="0" bIns="0" rtlCol="0" anchor="ctr"/>
-          <a:lstStyle/>
-          <a:p>
-            <a:pPr marL="0" indent="0" algn="r" rtl="1">
-              <a:buNone/>
-            </a:pPr>
-            <a:r>
-              <a:rPr lang="en-US" sz="1200" dirty="0">
-                <a:solidFill>
-                  <a:srgbClr val="5B6B7E"/>
-                </a:solidFill>
-                <a:latin typeface="Sahel" pitchFamily="34" charset="0"/>
-                <a:ea typeface="Sahel" pitchFamily="34" charset="-122"/>
-                <a:cs typeface="Sahel" pitchFamily="34" charset="-120"/>
-              </a:rPr>
-              <a:t>جدول ۶-۲ گزارش: پارامترهای آموزش و عملکرد عامل</a:t>
-            </a:r>
-            <a:endParaRPr lang="en-US" sz="1200" dirty="0"/>
-          </a:p>
-        </p:txBody>
-      </p:sp>
-      <p:sp>
-        <p:nvSpPr>
           <p:cNvPr id="6" name="Shape 3"/>
           <p:cNvSpPr/>
           <p:nvPr/>
@@ -10821,45 +11100,6 @@
       </p:pic>
       <p:sp>
         <p:nvSpPr>
-          <p:cNvPr id="6" name="Text 3"/>
-          <p:cNvSpPr/>
-          <p:nvPr/>
-        </p:nvSpPr>
-        <p:spPr>
-          <a:xfrm>
-            <a:off x="594360" y="5687568"/>
-            <a:ext cx="3657600" cy="274320"/>
-          </a:xfrm>
-          <a:prstGeom prst="rect">
-            <a:avLst/>
-          </a:prstGeom>
-          <a:noFill/>
-          <a:ln/>
-        </p:spPr>
-        <p:txBody>
-          <a:bodyPr wrap="square" lIns="0" tIns="0" rIns="0" bIns="0" rtlCol="0" anchor="ctr"/>
-          <a:lstStyle/>
-          <a:p>
-            <a:pPr marL="0" indent="0" algn="r" rtl="1">
-              <a:buNone/>
-            </a:pPr>
-            <a:r>
-              <a:rPr lang="en-US" sz="1200" dirty="0">
-                <a:solidFill>
-                  <a:srgbClr val="5B6B7E"/>
-                </a:solidFill>
-                <a:latin typeface="Sahel" pitchFamily="34" charset="0"/>
-                <a:ea typeface="Sahel" pitchFamily="34" charset="-122"/>
-                <a:cs typeface="Sahel" pitchFamily="34" charset="-120"/>
-              </a:rPr>
-              <a:t>منبع: گزارش پروژه — شکل ۶-۲</a:t>
-            </a:r>
-            <a:endParaRPr lang="en-US" sz="1200" dirty="0"/>
-          </a:p>
-        </p:txBody>
-      </p:sp>
-      <p:sp>
-        <p:nvSpPr>
           <p:cNvPr id="7" name="Text 4"/>
           <p:cNvSpPr/>
           <p:nvPr/>
@@ -12822,45 +13062,6 @@
       </p:pic>
       <p:sp>
         <p:nvSpPr>
-          <p:cNvPr id="6" name="Text 3"/>
-          <p:cNvSpPr/>
-          <p:nvPr/>
-        </p:nvSpPr>
-        <p:spPr>
-          <a:xfrm>
-            <a:off x="594360" y="5212080"/>
-            <a:ext cx="3657600" cy="274320"/>
-          </a:xfrm>
-          <a:prstGeom prst="rect">
-            <a:avLst/>
-          </a:prstGeom>
-          <a:noFill/>
-          <a:ln/>
-        </p:spPr>
-        <p:txBody>
-          <a:bodyPr wrap="square" lIns="0" tIns="0" rIns="0" bIns="0" rtlCol="0" anchor="ctr"/>
-          <a:lstStyle/>
-          <a:p>
-            <a:pPr marL="0" indent="0" algn="r" rtl="1">
-              <a:buNone/>
-            </a:pPr>
-            <a:r>
-              <a:rPr lang="en-US" sz="1200" dirty="0">
-                <a:solidFill>
-                  <a:srgbClr val="5B6B7E"/>
-                </a:solidFill>
-                <a:latin typeface="Sahel" pitchFamily="34" charset="0"/>
-                <a:ea typeface="Sahel" pitchFamily="34" charset="-122"/>
-                <a:cs typeface="Sahel" pitchFamily="34" charset="-120"/>
-              </a:rPr>
-              <a:t>منبع: گزارش پروژه — شکل ۷-۱</a:t>
-            </a:r>
-            <a:endParaRPr lang="en-US" sz="1200" dirty="0"/>
-          </a:p>
-        </p:txBody>
-      </p:sp>
-      <p:sp>
-        <p:nvSpPr>
           <p:cNvPr id="7" name="Text 4"/>
           <p:cNvSpPr/>
           <p:nvPr/>
@@ -14969,45 +15170,6 @@
           </a:prstGeom>
         </p:spPr>
       </p:pic>
-      <p:sp>
-        <p:nvSpPr>
-          <p:cNvPr id="6" name="Text 3"/>
-          <p:cNvSpPr/>
-          <p:nvPr/>
-        </p:nvSpPr>
-        <p:spPr>
-          <a:xfrm>
-            <a:off x="594360" y="5349240"/>
-            <a:ext cx="3657600" cy="274320"/>
-          </a:xfrm>
-          <a:prstGeom prst="rect">
-            <a:avLst/>
-          </a:prstGeom>
-          <a:noFill/>
-          <a:ln/>
-        </p:spPr>
-        <p:txBody>
-          <a:bodyPr wrap="square" lIns="0" tIns="0" rIns="0" bIns="0" rtlCol="0" anchor="ctr"/>
-          <a:lstStyle/>
-          <a:p>
-            <a:pPr marL="0" indent="0" algn="r" rtl="1">
-              <a:buNone/>
-            </a:pPr>
-            <a:r>
-              <a:rPr lang="en-US" sz="1200" dirty="0">
-                <a:solidFill>
-                  <a:srgbClr val="5B6B7E"/>
-                </a:solidFill>
-                <a:latin typeface="Sahel" pitchFamily="34" charset="0"/>
-                <a:ea typeface="Sahel" pitchFamily="34" charset="-122"/>
-                <a:cs typeface="Sahel" pitchFamily="34" charset="-120"/>
-              </a:rPr>
-              <a:t>منبع: گزارش پروژه — شکل ۸-۱</a:t>
-            </a:r>
-            <a:endParaRPr lang="en-US" sz="1200" dirty="0"/>
-          </a:p>
-        </p:txBody>
-      </p:sp>
       <p:sp>
         <p:nvSpPr>
           <p:cNvPr id="7" name="Text 4"/>

</xml_diff>